<commit_message>
add explanation for CIPCSL2.
</commit_message>
<xml_diff>
--- a/Src/Utilities/ChangeGrid/ChangeGrid.pptx
+++ b/Src/Utilities/ChangeGrid/ChangeGrid.pptx
@@ -6,9 +6,10 @@
   </p:sldMasterIdLst>
   <p:sldIdLst>
     <p:sldId id="260" r:id="rId2"/>
-    <p:sldId id="258" r:id="rId3"/>
-    <p:sldId id="257" r:id="rId4"/>
-    <p:sldId id="259" r:id="rId5"/>
+    <p:sldId id="261" r:id="rId3"/>
+    <p:sldId id="258" r:id="rId4"/>
+    <p:sldId id="257" r:id="rId5"/>
+    <p:sldId id="259" r:id="rId6"/>
   </p:sldIdLst>
   <p:sldSz cx="12192000" cy="6858000"/>
   <p:notesSz cx="6858000" cy="9144000"/>
@@ -244,7 +245,7 @@
           <a:p>
             <a:fld id="{FA9EA2C2-FD8A-4E4D-B649-B87E2A10C3B3}" type="datetimeFigureOut">
               <a:rPr lang="en-US" smtClean="0"/>
-              <a:t>8/28/2023</a:t>
+              <a:t>10/25/2024</a:t>
             </a:fld>
             <a:endParaRPr lang="en-US"/>
           </a:p>
@@ -412,7 +413,7 @@
           <a:p>
             <a:fld id="{FA9EA2C2-FD8A-4E4D-B649-B87E2A10C3B3}" type="datetimeFigureOut">
               <a:rPr lang="en-US" smtClean="0"/>
-              <a:t>8/28/2023</a:t>
+              <a:t>10/25/2024</a:t>
             </a:fld>
             <a:endParaRPr lang="en-US"/>
           </a:p>
@@ -590,7 +591,7 @@
           <a:p>
             <a:fld id="{FA9EA2C2-FD8A-4E4D-B649-B87E2A10C3B3}" type="datetimeFigureOut">
               <a:rPr lang="en-US" smtClean="0"/>
-              <a:t>8/28/2023</a:t>
+              <a:t>10/25/2024</a:t>
             </a:fld>
             <a:endParaRPr lang="en-US"/>
           </a:p>
@@ -758,7 +759,7 @@
           <a:p>
             <a:fld id="{FA9EA2C2-FD8A-4E4D-B649-B87E2A10C3B3}" type="datetimeFigureOut">
               <a:rPr lang="en-US" smtClean="0"/>
-              <a:t>8/28/2023</a:t>
+              <a:t>10/25/2024</a:t>
             </a:fld>
             <a:endParaRPr lang="en-US"/>
           </a:p>
@@ -1003,7 +1004,7 @@
           <a:p>
             <a:fld id="{FA9EA2C2-FD8A-4E4D-B649-B87E2A10C3B3}" type="datetimeFigureOut">
               <a:rPr lang="en-US" smtClean="0"/>
-              <a:t>8/28/2023</a:t>
+              <a:t>10/25/2024</a:t>
             </a:fld>
             <a:endParaRPr lang="en-US"/>
           </a:p>
@@ -1232,7 +1233,7 @@
           <a:p>
             <a:fld id="{FA9EA2C2-FD8A-4E4D-B649-B87E2A10C3B3}" type="datetimeFigureOut">
               <a:rPr lang="en-US" smtClean="0"/>
-              <a:t>8/28/2023</a:t>
+              <a:t>10/25/2024</a:t>
             </a:fld>
             <a:endParaRPr lang="en-US"/>
           </a:p>
@@ -1596,7 +1597,7 @@
           <a:p>
             <a:fld id="{FA9EA2C2-FD8A-4E4D-B649-B87E2A10C3B3}" type="datetimeFigureOut">
               <a:rPr lang="en-US" smtClean="0"/>
-              <a:t>8/28/2023</a:t>
+              <a:t>10/25/2024</a:t>
             </a:fld>
             <a:endParaRPr lang="en-US"/>
           </a:p>
@@ -1713,7 +1714,7 @@
           <a:p>
             <a:fld id="{FA9EA2C2-FD8A-4E4D-B649-B87E2A10C3B3}" type="datetimeFigureOut">
               <a:rPr lang="en-US" smtClean="0"/>
-              <a:t>8/28/2023</a:t>
+              <a:t>10/25/2024</a:t>
             </a:fld>
             <a:endParaRPr lang="en-US"/>
           </a:p>
@@ -1808,7 +1809,7 @@
           <a:p>
             <a:fld id="{FA9EA2C2-FD8A-4E4D-B649-B87E2A10C3B3}" type="datetimeFigureOut">
               <a:rPr lang="en-US" smtClean="0"/>
-              <a:t>8/28/2023</a:t>
+              <a:t>10/25/2024</a:t>
             </a:fld>
             <a:endParaRPr lang="en-US"/>
           </a:p>
@@ -2083,7 +2084,7 @@
           <a:p>
             <a:fld id="{FA9EA2C2-FD8A-4E4D-B649-B87E2A10C3B3}" type="datetimeFigureOut">
               <a:rPr lang="en-US" smtClean="0"/>
-              <a:t>8/28/2023</a:t>
+              <a:t>10/25/2024</a:t>
             </a:fld>
             <a:endParaRPr lang="en-US"/>
           </a:p>
@@ -2335,7 +2336,7 @@
           <a:p>
             <a:fld id="{FA9EA2C2-FD8A-4E4D-B649-B87E2A10C3B3}" type="datetimeFigureOut">
               <a:rPr lang="en-US" smtClean="0"/>
-              <a:t>8/28/2023</a:t>
+              <a:t>10/25/2024</a:t>
             </a:fld>
             <a:endParaRPr lang="en-US"/>
           </a:p>
@@ -2546,7 +2547,7 @@
           <a:p>
             <a:fld id="{FA9EA2C2-FD8A-4E4D-B649-B87E2A10C3B3}" type="datetimeFigureOut">
               <a:rPr lang="en-US" smtClean="0"/>
-              <a:t>8/28/2023</a:t>
+              <a:t>10/25/2024</a:t>
             </a:fld>
             <a:endParaRPr lang="en-US"/>
           </a:p>
@@ -4108,7 +4109,13 @@
       </p:grpSpPr>
       <p:sp>
         <p:nvSpPr>
-          <p:cNvPr id="2" name="Title 1"/>
+          <p:cNvPr id="2" name="Title 1">
+            <a:extLst>
+              <a:ext uri="{FF2B5EF4-FFF2-40B4-BE49-F238E27FC236}">
+                <a16:creationId xmlns:a16="http://schemas.microsoft.com/office/drawing/2014/main" id="{DF82880D-FF35-B968-F71D-AB97975DA590}"/>
+              </a:ext>
+            </a:extLst>
+          </p:cNvPr>
           <p:cNvSpPr>
             <a:spLocks noGrp="1"/>
           </p:cNvSpPr>
@@ -4123,22 +4130,28 @@
           <a:p>
             <a:r>
               <a:rPr lang="en-US" dirty="0"/>
-              <a:t>New or updated code (</a:t>
+              <a:t>For </a:t>
             </a:r>
             <a:r>
               <a:rPr lang="en-US" dirty="0" err="1"/>
-              <a:t>github</a:t>
-            </a:r>
-            <a:r>
-              <a:rPr lang="en-US" dirty="0"/>
-              <a:t>)</a:t>
-            </a:r>
-          </a:p>
-        </p:txBody>
-      </p:sp>
-      <p:sp>
-        <p:nvSpPr>
-          <p:cNvPr id="3" name="Content Placeholder 2"/>
+              <a:t>bck</a:t>
+            </a:r>
+            <a:r>
+              <a:rPr lang="en-US" dirty="0"/>
+              <a:t> files of CIPCSL2</a:t>
+            </a:r>
+          </a:p>
+        </p:txBody>
+      </p:sp>
+      <p:sp>
+        <p:nvSpPr>
+          <p:cNvPr id="3" name="Content Placeholder 2">
+            <a:extLst>
+              <a:ext uri="{FF2B5EF4-FFF2-40B4-BE49-F238E27FC236}">
+                <a16:creationId xmlns:a16="http://schemas.microsoft.com/office/drawing/2014/main" id="{97DB2FBD-784F-AAB0-9E98-215DC99E5E27}"/>
+              </a:ext>
+            </a:extLst>
+          </p:cNvPr>
           <p:cNvSpPr>
             <a:spLocks noGrp="1"/>
           </p:cNvSpPr>
@@ -4146,47 +4159,1014 @@
             <p:ph idx="1"/>
           </p:nvPr>
         </p:nvSpPr>
-        <p:spPr/>
-        <p:txBody>
-          <a:bodyPr/>
-          <a:lstStyle/>
-          <a:p>
-            <a:r>
-              <a:rPr lang="en-US" dirty="0"/>
-              <a:t>Add Utilities/</a:t>
-            </a:r>
-            <a:r>
-              <a:rPr lang="en-US" dirty="0" err="1"/>
+        <p:spPr>
+          <a:xfrm>
+            <a:off x="288758" y="1825625"/>
+            <a:ext cx="5011153" cy="4351338"/>
+          </a:xfrm>
+        </p:spPr>
+        <p:txBody>
+          <a:bodyPr>
+            <a:normAutofit/>
+          </a:bodyPr>
+          <a:lstStyle/>
+          <a:p>
+            <a:r>
+              <a:rPr lang="en-US" sz="2000" dirty="0"/>
+              <a:t>Change only conc-phi*.</a:t>
+            </a:r>
+            <a:r>
+              <a:rPr lang="en-US" sz="2000" dirty="0" err="1"/>
+              <a:t>bck</a:t>
+            </a:r>
+            <a:r>
+              <a:rPr lang="en-US" sz="2000" dirty="0"/>
+              <a:t> to conc-phi*.bck2.</a:t>
+            </a:r>
+          </a:p>
+          <a:p>
+            <a:r>
+              <a:rPr lang="en-US" sz="2000" dirty="0"/>
+              <a:t>The other variables such as </a:t>
+            </a:r>
+            <a:r>
+              <a:rPr lang="en-US" sz="1800" dirty="0">
+                <a:effectLst/>
+                <a:latin typeface="Calibri" panose="020F0502020204030204" pitchFamily="34" charset="0"/>
+                <a:ea typeface="Yu Gothic" panose="020B0400000000000000" pitchFamily="34" charset="-128"/>
+              </a:rPr>
+              <a:t>conc-</a:t>
+            </a:r>
+            <a:r>
+              <a:rPr lang="en-US" sz="1800" dirty="0" err="1">
+                <a:effectLst/>
+                <a:latin typeface="Calibri" panose="020F0502020204030204" pitchFamily="34" charset="0"/>
+                <a:ea typeface="Yu Gothic" panose="020B0400000000000000" pitchFamily="34" charset="-128"/>
+              </a:rPr>
+              <a:t>clr</a:t>
+            </a:r>
+            <a:r>
+              <a:rPr lang="en-US" sz="1800" dirty="0">
+                <a:effectLst/>
+                <a:latin typeface="Calibri" panose="020F0502020204030204" pitchFamily="34" charset="0"/>
+                <a:ea typeface="Yu Gothic" panose="020B0400000000000000" pitchFamily="34" charset="-128"/>
+              </a:rPr>
+              <a:t>*, conc-face*, conc-sig* will be generated in main.cpp, especially made for the restart after </a:t>
+            </a:r>
+            <a:r>
+              <a:rPr lang="en-US" sz="1800" dirty="0" err="1">
+                <a:effectLst/>
+                <a:latin typeface="Calibri" panose="020F0502020204030204" pitchFamily="34" charset="0"/>
+                <a:ea typeface="Yu Gothic" panose="020B0400000000000000" pitchFamily="34" charset="-128"/>
+              </a:rPr>
               <a:t>ChangeGrid</a:t>
             </a:r>
-            <a:endParaRPr lang="en-US" dirty="0"/>
-          </a:p>
-          <a:p>
-            <a:r>
-              <a:rPr lang="en-US" dirty="0"/>
-              <a:t>Modify </a:t>
-            </a:r>
-            <a:r>
-              <a:rPr lang="en-US" dirty="0" err="1"/>
-              <a:t>domain.h</a:t>
-            </a:r>
-            <a:r>
-              <a:rPr lang="en-US" dirty="0"/>
-              <a:t>, and add domain_save.cpp</a:t>
-            </a:r>
-          </a:p>
-          <a:p>
-            <a:r>
-              <a:rPr lang="en-US" dirty="0"/>
-              <a:t>main.cpp (add </a:t>
-            </a:r>
-            <a:r>
-              <a:rPr lang="en-US" dirty="0" err="1"/>
-              <a:t>dom.save</a:t>
-            </a:r>
-            <a:r>
-              <a:rPr lang="en-US" dirty="0"/>
-              <a:t>(g4.dom))</a:t>
+            <a:r>
+              <a:rPr lang="en-US" sz="1800" dirty="0">
+                <a:effectLst/>
+                <a:latin typeface="Calibri" panose="020F0502020204030204" pitchFamily="34" charset="0"/>
+                <a:ea typeface="Yu Gothic" panose="020B0400000000000000" pitchFamily="34" charset="-128"/>
+              </a:rPr>
+              <a:t>.</a:t>
+            </a:r>
+          </a:p>
+          <a:p>
+            <a:r>
+              <a:rPr lang="en-US" sz="1800" dirty="0">
+                <a:latin typeface="Calibri" panose="020F0502020204030204" pitchFamily="34" charset="0"/>
+                <a:ea typeface="Yu Gothic" panose="020B0400000000000000" pitchFamily="34" charset="-128"/>
+              </a:rPr>
+              <a:t>The code on the right is a restart part of main.cpp.</a:t>
+            </a:r>
+            <a:br>
+              <a:rPr lang="en-US" sz="1800" dirty="0">
+                <a:latin typeface="Calibri" panose="020F0502020204030204" pitchFamily="34" charset="0"/>
+                <a:ea typeface="Yu Gothic" panose="020B0400000000000000" pitchFamily="34" charset="-128"/>
+              </a:rPr>
+            </a:br>
+            <a:r>
+              <a:rPr lang="en-US" sz="1800" dirty="0">
+                <a:latin typeface="Calibri" panose="020F0502020204030204" pitchFamily="34" charset="0"/>
+                <a:ea typeface="Yu Gothic" panose="020B0400000000000000" pitchFamily="34" charset="-128"/>
+              </a:rPr>
+              <a:t>When you restart after </a:t>
+            </a:r>
+            <a:r>
+              <a:rPr lang="en-US" sz="1800" dirty="0" err="1">
+                <a:latin typeface="Calibri" panose="020F0502020204030204" pitchFamily="34" charset="0"/>
+                <a:ea typeface="Yu Gothic" panose="020B0400000000000000" pitchFamily="34" charset="-128"/>
+              </a:rPr>
+              <a:t>ChangeGrid</a:t>
+            </a:r>
+            <a:r>
+              <a:rPr lang="en-US" sz="1800" dirty="0">
+                <a:latin typeface="Calibri" panose="020F0502020204030204" pitchFamily="34" charset="0"/>
+                <a:ea typeface="Yu Gothic" panose="020B0400000000000000" pitchFamily="34" charset="-128"/>
+              </a:rPr>
+              <a:t>, set #if 1.</a:t>
+            </a:r>
+            <a:br>
+              <a:rPr lang="en-US" sz="1800" dirty="0">
+                <a:latin typeface="Calibri" panose="020F0502020204030204" pitchFamily="34" charset="0"/>
+                <a:ea typeface="Yu Gothic" panose="020B0400000000000000" pitchFamily="34" charset="-128"/>
+              </a:rPr>
+            </a:br>
+            <a:r>
+              <a:rPr lang="en-US" sz="1800" dirty="0">
+                <a:latin typeface="Calibri" panose="020F0502020204030204" pitchFamily="34" charset="0"/>
+                <a:ea typeface="Yu Gothic" panose="020B0400000000000000" pitchFamily="34" charset="-128"/>
+              </a:rPr>
+              <a:t>When you restart normally, set #if 0.  </a:t>
+            </a:r>
+            <a:endParaRPr lang="en-US" sz="2000" dirty="0"/>
+          </a:p>
+        </p:txBody>
+      </p:sp>
+      <p:sp>
+        <p:nvSpPr>
+          <p:cNvPr id="5" name="Content Placeholder 2">
+            <a:extLst>
+              <a:ext uri="{FF2B5EF4-FFF2-40B4-BE49-F238E27FC236}">
+                <a16:creationId xmlns:a16="http://schemas.microsoft.com/office/drawing/2014/main" id="{3C073204-C08D-E177-0B1D-C732296DA200}"/>
+              </a:ext>
+            </a:extLst>
+          </p:cNvPr>
+          <p:cNvSpPr txBox="1">
+            <a:spLocks/>
+          </p:cNvSpPr>
+          <p:nvPr/>
+        </p:nvSpPr>
+        <p:spPr>
+          <a:xfrm>
+            <a:off x="6892091" y="1253331"/>
+            <a:ext cx="4461711" cy="4351338"/>
+          </a:xfrm>
+          <a:prstGeom prst="rect">
+            <a:avLst/>
+          </a:prstGeom>
+        </p:spPr>
+        <p:txBody>
+          <a:bodyPr vert="horz" lIns="91440" tIns="45720" rIns="91440" bIns="45720" rtlCol="0">
+            <a:noAutofit/>
+          </a:bodyPr>
+          <a:lstStyle>
+            <a:lvl1pPr marL="228600" indent="-228600" algn="l" defTabSz="914400" rtl="0" eaLnBrk="1" latinLnBrk="0" hangingPunct="1">
+              <a:lnSpc>
+                <a:spcPct val="90000"/>
+              </a:lnSpc>
+              <a:spcBef>
+                <a:spcPts val="1000"/>
+              </a:spcBef>
+              <a:buFont typeface="Arial" panose="020B0604020202020204" pitchFamily="34" charset="0"/>
+              <a:buChar char="•"/>
+              <a:defRPr sz="2800" kern="1200">
+                <a:solidFill>
+                  <a:schemeClr val="tx1"/>
+                </a:solidFill>
+                <a:latin typeface="+mn-lt"/>
+                <a:ea typeface="+mn-ea"/>
+                <a:cs typeface="+mn-cs"/>
+              </a:defRPr>
+            </a:lvl1pPr>
+            <a:lvl2pPr marL="685800" indent="-228600" algn="l" defTabSz="914400" rtl="0" eaLnBrk="1" latinLnBrk="0" hangingPunct="1">
+              <a:lnSpc>
+                <a:spcPct val="90000"/>
+              </a:lnSpc>
+              <a:spcBef>
+                <a:spcPts val="500"/>
+              </a:spcBef>
+              <a:buFont typeface="Arial" panose="020B0604020202020204" pitchFamily="34" charset="0"/>
+              <a:buChar char="•"/>
+              <a:defRPr sz="2400" kern="1200">
+                <a:solidFill>
+                  <a:schemeClr val="tx1"/>
+                </a:solidFill>
+                <a:latin typeface="+mn-lt"/>
+                <a:ea typeface="+mn-ea"/>
+                <a:cs typeface="+mn-cs"/>
+              </a:defRPr>
+            </a:lvl2pPr>
+            <a:lvl3pPr marL="1143000" indent="-228600" algn="l" defTabSz="914400" rtl="0" eaLnBrk="1" latinLnBrk="0" hangingPunct="1">
+              <a:lnSpc>
+                <a:spcPct val="90000"/>
+              </a:lnSpc>
+              <a:spcBef>
+                <a:spcPts val="500"/>
+              </a:spcBef>
+              <a:buFont typeface="Arial" panose="020B0604020202020204" pitchFamily="34" charset="0"/>
+              <a:buChar char="•"/>
+              <a:defRPr sz="2000" kern="1200">
+                <a:solidFill>
+                  <a:schemeClr val="tx1"/>
+                </a:solidFill>
+                <a:latin typeface="+mn-lt"/>
+                <a:ea typeface="+mn-ea"/>
+                <a:cs typeface="+mn-cs"/>
+              </a:defRPr>
+            </a:lvl3pPr>
+            <a:lvl4pPr marL="1600200" indent="-228600" algn="l" defTabSz="914400" rtl="0" eaLnBrk="1" latinLnBrk="0" hangingPunct="1">
+              <a:lnSpc>
+                <a:spcPct val="90000"/>
+              </a:lnSpc>
+              <a:spcBef>
+                <a:spcPts val="500"/>
+              </a:spcBef>
+              <a:buFont typeface="Arial" panose="020B0604020202020204" pitchFamily="34" charset="0"/>
+              <a:buChar char="•"/>
+              <a:defRPr sz="1800" kern="1200">
+                <a:solidFill>
+                  <a:schemeClr val="tx1"/>
+                </a:solidFill>
+                <a:latin typeface="+mn-lt"/>
+                <a:ea typeface="+mn-ea"/>
+                <a:cs typeface="+mn-cs"/>
+              </a:defRPr>
+            </a:lvl4pPr>
+            <a:lvl5pPr marL="2057400" indent="-228600" algn="l" defTabSz="914400" rtl="0" eaLnBrk="1" latinLnBrk="0" hangingPunct="1">
+              <a:lnSpc>
+                <a:spcPct val="90000"/>
+              </a:lnSpc>
+              <a:spcBef>
+                <a:spcPts val="500"/>
+              </a:spcBef>
+              <a:buFont typeface="Arial" panose="020B0604020202020204" pitchFamily="34" charset="0"/>
+              <a:buChar char="•"/>
+              <a:defRPr sz="1800" kern="1200">
+                <a:solidFill>
+                  <a:schemeClr val="tx1"/>
+                </a:solidFill>
+                <a:latin typeface="+mn-lt"/>
+                <a:ea typeface="+mn-ea"/>
+                <a:cs typeface="+mn-cs"/>
+              </a:defRPr>
+            </a:lvl5pPr>
+            <a:lvl6pPr marL="2514600" indent="-228600" algn="l" defTabSz="914400" rtl="0" eaLnBrk="1" latinLnBrk="0" hangingPunct="1">
+              <a:lnSpc>
+                <a:spcPct val="90000"/>
+              </a:lnSpc>
+              <a:spcBef>
+                <a:spcPts val="500"/>
+              </a:spcBef>
+              <a:buFont typeface="Arial" panose="020B0604020202020204" pitchFamily="34" charset="0"/>
+              <a:buChar char="•"/>
+              <a:defRPr sz="1800" kern="1200">
+                <a:solidFill>
+                  <a:schemeClr val="tx1"/>
+                </a:solidFill>
+                <a:latin typeface="+mn-lt"/>
+                <a:ea typeface="+mn-ea"/>
+                <a:cs typeface="+mn-cs"/>
+              </a:defRPr>
+            </a:lvl6pPr>
+            <a:lvl7pPr marL="2971800" indent="-228600" algn="l" defTabSz="914400" rtl="0" eaLnBrk="1" latinLnBrk="0" hangingPunct="1">
+              <a:lnSpc>
+                <a:spcPct val="90000"/>
+              </a:lnSpc>
+              <a:spcBef>
+                <a:spcPts val="500"/>
+              </a:spcBef>
+              <a:buFont typeface="Arial" panose="020B0604020202020204" pitchFamily="34" charset="0"/>
+              <a:buChar char="•"/>
+              <a:defRPr sz="1800" kern="1200">
+                <a:solidFill>
+                  <a:schemeClr val="tx1"/>
+                </a:solidFill>
+                <a:latin typeface="+mn-lt"/>
+                <a:ea typeface="+mn-ea"/>
+                <a:cs typeface="+mn-cs"/>
+              </a:defRPr>
+            </a:lvl7pPr>
+            <a:lvl8pPr marL="3429000" indent="-228600" algn="l" defTabSz="914400" rtl="0" eaLnBrk="1" latinLnBrk="0" hangingPunct="1">
+              <a:lnSpc>
+                <a:spcPct val="90000"/>
+              </a:lnSpc>
+              <a:spcBef>
+                <a:spcPts val="500"/>
+              </a:spcBef>
+              <a:buFont typeface="Arial" panose="020B0604020202020204" pitchFamily="34" charset="0"/>
+              <a:buChar char="•"/>
+              <a:defRPr sz="1800" kern="1200">
+                <a:solidFill>
+                  <a:schemeClr val="tx1"/>
+                </a:solidFill>
+                <a:latin typeface="+mn-lt"/>
+                <a:ea typeface="+mn-ea"/>
+                <a:cs typeface="+mn-cs"/>
+              </a:defRPr>
+            </a:lvl8pPr>
+            <a:lvl9pPr marL="3886200" indent="-228600" algn="l" defTabSz="914400" rtl="0" eaLnBrk="1" latinLnBrk="0" hangingPunct="1">
+              <a:lnSpc>
+                <a:spcPct val="90000"/>
+              </a:lnSpc>
+              <a:spcBef>
+                <a:spcPts val="500"/>
+              </a:spcBef>
+              <a:buFont typeface="Arial" panose="020B0604020202020204" pitchFamily="34" charset="0"/>
+              <a:buChar char="•"/>
+              <a:defRPr sz="1800" kern="1200">
+                <a:solidFill>
+                  <a:schemeClr val="tx1"/>
+                </a:solidFill>
+                <a:latin typeface="+mn-lt"/>
+                <a:ea typeface="+mn-ea"/>
+                <a:cs typeface="+mn-cs"/>
+              </a:defRPr>
+            </a:lvl9pPr>
+          </a:lstStyle>
+          <a:p>
+            <a:pPr marL="0" indent="0">
+              <a:lnSpc>
+                <a:spcPct val="100000"/>
+              </a:lnSpc>
+              <a:spcBef>
+                <a:spcPts val="0"/>
+              </a:spcBef>
+              <a:buNone/>
+            </a:pPr>
+            <a:r>
+              <a:rPr lang="en-US" sz="1200" dirty="0"/>
+              <a:t> if( restart ) {</a:t>
+            </a:r>
+          </a:p>
+          <a:p>
+            <a:pPr marL="0" indent="0">
+              <a:lnSpc>
+                <a:spcPct val="100000"/>
+              </a:lnSpc>
+              <a:spcBef>
+                <a:spcPts val="0"/>
+              </a:spcBef>
+              <a:buNone/>
+            </a:pPr>
+            <a:r>
+              <a:rPr lang="en-US" sz="1200" dirty="0"/>
+              <a:t>    </a:t>
+            </a:r>
+            <a:r>
+              <a:rPr lang="en-US" sz="1200" dirty="0" err="1"/>
+              <a:t>uvw</a:t>
+            </a:r>
+            <a:r>
+              <a:rPr lang="en-US" sz="1200" dirty="0"/>
+              <a:t>   .load("</a:t>
+            </a:r>
+            <a:r>
+              <a:rPr lang="en-US" sz="1200" dirty="0" err="1"/>
+              <a:t>uvw</a:t>
+            </a:r>
+            <a:r>
+              <a:rPr lang="en-US" sz="1200" dirty="0"/>
+              <a:t>", </a:t>
+            </a:r>
+            <a:r>
+              <a:rPr lang="en-US" sz="1200" dirty="0" err="1"/>
+              <a:t>ts</a:t>
+            </a:r>
+            <a:r>
+              <a:rPr lang="en-US" sz="1200" dirty="0"/>
+              <a:t>);</a:t>
+            </a:r>
+          </a:p>
+          <a:p>
+            <a:pPr marL="0" indent="0">
+              <a:lnSpc>
+                <a:spcPct val="100000"/>
+              </a:lnSpc>
+              <a:spcBef>
+                <a:spcPts val="0"/>
+              </a:spcBef>
+              <a:buNone/>
+            </a:pPr>
+            <a:r>
+              <a:rPr lang="en-US" sz="1200" dirty="0"/>
+              <a:t>    press .load("press", </a:t>
+            </a:r>
+            <a:r>
+              <a:rPr lang="en-US" sz="1200" dirty="0" err="1"/>
+              <a:t>ts</a:t>
+            </a:r>
+            <a:r>
+              <a:rPr lang="en-US" sz="1200" dirty="0"/>
+              <a:t>);</a:t>
+            </a:r>
+          </a:p>
+          <a:p>
+            <a:pPr marL="0" indent="0">
+              <a:lnSpc>
+                <a:spcPct val="100000"/>
+              </a:lnSpc>
+              <a:spcBef>
+                <a:spcPts val="0"/>
+              </a:spcBef>
+              <a:buNone/>
+            </a:pPr>
+            <a:r>
+              <a:rPr lang="en-US" sz="1200" dirty="0"/>
+              <a:t>    </a:t>
+            </a:r>
+            <a:r>
+              <a:rPr lang="en-US" sz="1200" dirty="0" err="1"/>
+              <a:t>tpr</a:t>
+            </a:r>
+            <a:r>
+              <a:rPr lang="en-US" sz="1200" dirty="0"/>
+              <a:t>   .load("</a:t>
+            </a:r>
+            <a:r>
+              <a:rPr lang="en-US" sz="1200" dirty="0" err="1"/>
+              <a:t>tpr</a:t>
+            </a:r>
+            <a:r>
+              <a:rPr lang="en-US" sz="1200" dirty="0"/>
+              <a:t>", </a:t>
+            </a:r>
+            <a:r>
+              <a:rPr lang="en-US" sz="1200" dirty="0" err="1"/>
+              <a:t>ts</a:t>
+            </a:r>
+            <a:r>
+              <a:rPr lang="en-US" sz="1200" dirty="0"/>
+              <a:t>);</a:t>
+            </a:r>
+          </a:p>
+          <a:p>
+            <a:pPr marL="0" indent="0">
+              <a:lnSpc>
+                <a:spcPct val="100000"/>
+              </a:lnSpc>
+              <a:spcBef>
+                <a:spcPts val="0"/>
+              </a:spcBef>
+              <a:buNone/>
+            </a:pPr>
+            <a:r>
+              <a:rPr lang="en-US" sz="1200" dirty="0">
+                <a:solidFill>
+                  <a:srgbClr val="FF0000"/>
+                </a:solidFill>
+              </a:rPr>
+              <a:t>#if 0</a:t>
+            </a:r>
+          </a:p>
+          <a:p>
+            <a:pPr marL="0" indent="0">
+              <a:lnSpc>
+                <a:spcPct val="100000"/>
+              </a:lnSpc>
+              <a:spcBef>
+                <a:spcPts val="0"/>
+              </a:spcBef>
+              <a:buNone/>
+            </a:pPr>
+            <a:r>
+              <a:rPr lang="en-US" sz="1200" dirty="0"/>
+              <a:t>    /* normal start */</a:t>
+            </a:r>
+          </a:p>
+          <a:p>
+            <a:pPr marL="0" indent="0">
+              <a:lnSpc>
+                <a:spcPct val="100000"/>
+              </a:lnSpc>
+              <a:spcBef>
+                <a:spcPts val="0"/>
+              </a:spcBef>
+              <a:buNone/>
+            </a:pPr>
+            <a:r>
+              <a:rPr lang="en-US" sz="1200" dirty="0"/>
+              <a:t>    conc  .load("conc", </a:t>
+            </a:r>
+            <a:r>
+              <a:rPr lang="en-US" sz="1200" dirty="0" err="1"/>
+              <a:t>ts</a:t>
+            </a:r>
+            <a:r>
+              <a:rPr lang="en-US" sz="1200" dirty="0"/>
+              <a:t>);</a:t>
+            </a:r>
+          </a:p>
+          <a:p>
+            <a:pPr marL="0" indent="0">
+              <a:lnSpc>
+                <a:spcPct val="100000"/>
+              </a:lnSpc>
+              <a:spcBef>
+                <a:spcPts val="0"/>
+              </a:spcBef>
+              <a:buNone/>
+            </a:pPr>
+            <a:r>
+              <a:rPr lang="en-US" sz="1200" dirty="0"/>
+              <a:t>    </a:t>
+            </a:r>
+            <a:r>
+              <a:rPr lang="en-US" sz="1200" dirty="0" err="1"/>
+              <a:t>nucl</a:t>
+            </a:r>
+            <a:r>
+              <a:rPr lang="en-US" sz="1200" dirty="0"/>
+              <a:t>  .load("</a:t>
+            </a:r>
+            <a:r>
+              <a:rPr lang="en-US" sz="1200" dirty="0" err="1"/>
+              <a:t>nucl</a:t>
+            </a:r>
+            <a:r>
+              <a:rPr lang="en-US" sz="1200" dirty="0"/>
+              <a:t>", </a:t>
+            </a:r>
+            <a:r>
+              <a:rPr lang="en-US" sz="1200" dirty="0" err="1"/>
+              <a:t>ts</a:t>
+            </a:r>
+            <a:r>
+              <a:rPr lang="en-US" sz="1200" dirty="0"/>
+              <a:t>);</a:t>
+            </a:r>
+          </a:p>
+          <a:p>
+            <a:pPr marL="0" indent="0">
+              <a:lnSpc>
+                <a:spcPct val="100000"/>
+              </a:lnSpc>
+              <a:spcBef>
+                <a:spcPts val="0"/>
+              </a:spcBef>
+              <a:buNone/>
+            </a:pPr>
+            <a:r>
+              <a:rPr lang="en-US" sz="1200" dirty="0"/>
+              <a:t>    wd    .load("wd",   </a:t>
+            </a:r>
+            <a:r>
+              <a:rPr lang="en-US" sz="1200" dirty="0" err="1"/>
+              <a:t>ts</a:t>
+            </a:r>
+            <a:r>
+              <a:rPr lang="en-US" sz="1200" dirty="0"/>
+              <a:t>);</a:t>
+            </a:r>
+          </a:p>
+          <a:p>
+            <a:pPr marL="0" indent="0">
+              <a:lnSpc>
+                <a:spcPct val="100000"/>
+              </a:lnSpc>
+              <a:spcBef>
+                <a:spcPts val="0"/>
+              </a:spcBef>
+              <a:buNone/>
+            </a:pPr>
+            <a:r>
+              <a:rPr lang="en-US" sz="1200" dirty="0"/>
+              <a:t>#else</a:t>
+            </a:r>
+          </a:p>
+          <a:p>
+            <a:pPr marL="0" indent="0">
+              <a:lnSpc>
+                <a:spcPct val="100000"/>
+              </a:lnSpc>
+              <a:spcBef>
+                <a:spcPts val="0"/>
+              </a:spcBef>
+              <a:buNone/>
+            </a:pPr>
+            <a:r>
+              <a:rPr lang="en-US" sz="1200" dirty="0"/>
+              <a:t>    /* after </a:t>
+            </a:r>
+            <a:r>
+              <a:rPr lang="en-US" sz="1200" dirty="0" err="1"/>
+              <a:t>changeGrid</a:t>
+            </a:r>
+            <a:r>
+              <a:rPr lang="en-US" sz="1200" dirty="0"/>
+              <a:t> */</a:t>
+            </a:r>
+          </a:p>
+          <a:p>
+            <a:pPr marL="0" indent="0">
+              <a:lnSpc>
+                <a:spcPct val="100000"/>
+              </a:lnSpc>
+              <a:spcBef>
+                <a:spcPts val="0"/>
+              </a:spcBef>
+              <a:buNone/>
+            </a:pPr>
+            <a:r>
+              <a:rPr lang="en-US" sz="1200" dirty="0"/>
+              <a:t>    /* load conc-phi as a scalar */</a:t>
+            </a:r>
+          </a:p>
+          <a:p>
+            <a:pPr marL="0" indent="0">
+              <a:lnSpc>
+                <a:spcPct val="100000"/>
+              </a:lnSpc>
+              <a:spcBef>
+                <a:spcPts val="0"/>
+              </a:spcBef>
+              <a:buNone/>
+            </a:pPr>
+            <a:r>
+              <a:rPr lang="en-US" sz="1200" dirty="0"/>
+              <a:t>    </a:t>
+            </a:r>
+            <a:r>
+              <a:rPr lang="en-US" sz="1200" dirty="0" err="1"/>
+              <a:t>c.load</a:t>
+            </a:r>
+            <a:r>
+              <a:rPr lang="en-US" sz="1200" dirty="0"/>
+              <a:t>("conc-phi", </a:t>
+            </a:r>
+            <a:r>
+              <a:rPr lang="en-US" sz="1200" dirty="0" err="1"/>
+              <a:t>ts</a:t>
+            </a:r>
+            <a:r>
+              <a:rPr lang="en-US" sz="1200" dirty="0"/>
+              <a:t>);</a:t>
+            </a:r>
+          </a:p>
+          <a:p>
+            <a:pPr marL="0" indent="0">
+              <a:lnSpc>
+                <a:spcPct val="100000"/>
+              </a:lnSpc>
+              <a:spcBef>
+                <a:spcPts val="0"/>
+              </a:spcBef>
+              <a:buNone/>
+            </a:pPr>
+            <a:r>
+              <a:rPr lang="en-US" sz="1200" dirty="0"/>
+              <a:t>    </a:t>
+            </a:r>
+            <a:r>
+              <a:rPr lang="en-US" sz="1200" dirty="0" err="1"/>
+              <a:t>c.exchange_all</a:t>
+            </a:r>
+            <a:r>
+              <a:rPr lang="en-US" sz="1200" dirty="0"/>
+              <a:t>();</a:t>
+            </a:r>
+          </a:p>
+          <a:p>
+            <a:pPr marL="0" indent="0">
+              <a:lnSpc>
+                <a:spcPct val="100000"/>
+              </a:lnSpc>
+              <a:spcBef>
+                <a:spcPts val="0"/>
+              </a:spcBef>
+              <a:buNone/>
+            </a:pPr>
+            <a:r>
+              <a:rPr lang="en-US" sz="1200" dirty="0"/>
+              <a:t>    /* calculate conc-sigma etc. */</a:t>
+            </a:r>
+          </a:p>
+          <a:p>
+            <a:pPr marL="0" indent="0">
+              <a:lnSpc>
+                <a:spcPct val="100000"/>
+              </a:lnSpc>
+              <a:spcBef>
+                <a:spcPts val="0"/>
+              </a:spcBef>
+              <a:buNone/>
+            </a:pPr>
+            <a:r>
+              <a:rPr lang="en-US" sz="1200" dirty="0"/>
+              <a:t>    </a:t>
+            </a:r>
+            <a:r>
+              <a:rPr lang="en-US" sz="1200" dirty="0" err="1"/>
+              <a:t>conc.init</a:t>
+            </a:r>
+            <a:r>
+              <a:rPr lang="en-US" sz="1200" dirty="0"/>
+              <a:t>();</a:t>
+            </a:r>
+          </a:p>
+          <a:p>
+            <a:pPr marL="0" indent="0">
+              <a:lnSpc>
+                <a:spcPct val="100000"/>
+              </a:lnSpc>
+              <a:spcBef>
+                <a:spcPts val="0"/>
+              </a:spcBef>
+              <a:buNone/>
+            </a:pPr>
+            <a:r>
+              <a:rPr lang="en-US" sz="1200" dirty="0"/>
+              <a:t>    /* </a:t>
+            </a:r>
+            <a:r>
+              <a:rPr lang="en-US" sz="1200" dirty="0" err="1"/>
+              <a:t>zsite</a:t>
+            </a:r>
+            <a:r>
+              <a:rPr lang="en-US" sz="1200" dirty="0"/>
+              <a:t> can be changed */</a:t>
+            </a:r>
+          </a:p>
+          <a:p>
+            <a:pPr marL="0" indent="0">
+              <a:lnSpc>
+                <a:spcPct val="100000"/>
+              </a:lnSpc>
+              <a:spcBef>
+                <a:spcPts val="0"/>
+              </a:spcBef>
+              <a:buNone/>
+            </a:pPr>
+            <a:r>
+              <a:rPr lang="en-US" sz="1200" dirty="0"/>
+              <a:t>    real </a:t>
+            </a:r>
+            <a:r>
+              <a:rPr lang="en-US" sz="1200" dirty="0" err="1"/>
+              <a:t>zsite</a:t>
+            </a:r>
+            <a:r>
+              <a:rPr lang="en-US" sz="1200" dirty="0"/>
+              <a:t>=</a:t>
+            </a:r>
+            <a:r>
+              <a:rPr lang="en-US" sz="1200" dirty="0" err="1"/>
+              <a:t>rseed</a:t>
+            </a:r>
+            <a:r>
+              <a:rPr lang="en-US" sz="1200" dirty="0"/>
+              <a:t>*cos(</a:t>
+            </a:r>
+            <a:r>
+              <a:rPr lang="en-US" sz="1200" dirty="0" err="1"/>
+              <a:t>conc.get_cangle</a:t>
+            </a:r>
+            <a:r>
+              <a:rPr lang="en-US" sz="1200" dirty="0"/>
+              <a:t>()/180.0*boil::pi);</a:t>
+            </a:r>
+          </a:p>
+          <a:p>
+            <a:pPr marL="0" indent="0">
+              <a:lnSpc>
+                <a:spcPct val="100000"/>
+              </a:lnSpc>
+              <a:spcBef>
+                <a:spcPts val="0"/>
+              </a:spcBef>
+              <a:buNone/>
+            </a:pPr>
+            <a:r>
+              <a:rPr lang="en-US" sz="1200" dirty="0"/>
+              <a:t>    boil::</a:t>
+            </a:r>
+            <a:r>
+              <a:rPr lang="en-US" sz="1200" dirty="0" err="1"/>
+              <a:t>oout</a:t>
+            </a:r>
+            <a:r>
+              <a:rPr lang="en-US" sz="1200" dirty="0"/>
+              <a:t>&lt;&lt;"</a:t>
+            </a:r>
+            <a:r>
+              <a:rPr lang="en-US" sz="1200" dirty="0" err="1"/>
+              <a:t>main:change_site_z</a:t>
+            </a:r>
+            <a:r>
+              <a:rPr lang="en-US" sz="1200" dirty="0"/>
+              <a:t>= "&lt;&lt;</a:t>
+            </a:r>
+            <a:r>
+              <a:rPr lang="en-US" sz="1200" dirty="0" err="1"/>
+              <a:t>zsite</a:t>
+            </a:r>
+            <a:r>
+              <a:rPr lang="en-US" sz="1200" dirty="0"/>
+              <a:t>&lt;&lt;" "&lt;&lt;</a:t>
+            </a:r>
+            <a:r>
+              <a:rPr lang="en-US" sz="1200" dirty="0" err="1"/>
+              <a:t>rseed</a:t>
+            </a:r>
+            <a:r>
+              <a:rPr lang="en-US" sz="1200" dirty="0"/>
+              <a:t>&lt;&lt;"\n";</a:t>
+            </a:r>
+          </a:p>
+          <a:p>
+            <a:pPr marL="0" indent="0">
+              <a:lnSpc>
+                <a:spcPct val="100000"/>
+              </a:lnSpc>
+              <a:spcBef>
+                <a:spcPts val="0"/>
+              </a:spcBef>
+              <a:buNone/>
+            </a:pPr>
+            <a:r>
+              <a:rPr lang="en-US" sz="1200" dirty="0"/>
+              <a:t>    </a:t>
+            </a:r>
+            <a:r>
+              <a:rPr lang="en-US" sz="1200" dirty="0" err="1"/>
+              <a:t>nucl</a:t>
+            </a:r>
+            <a:r>
+              <a:rPr lang="en-US" sz="1200" dirty="0"/>
+              <a:t>  .load("</a:t>
+            </a:r>
+            <a:r>
+              <a:rPr lang="en-US" sz="1200" dirty="0" err="1"/>
+              <a:t>nucl</a:t>
+            </a:r>
+            <a:r>
+              <a:rPr lang="en-US" sz="1200" dirty="0"/>
+              <a:t>", </a:t>
+            </a:r>
+            <a:r>
+              <a:rPr lang="en-US" sz="1200" dirty="0" err="1"/>
+              <a:t>ts</a:t>
+            </a:r>
+            <a:r>
+              <a:rPr lang="en-US" sz="1200" dirty="0"/>
+              <a:t>, &amp;</a:t>
+            </a:r>
+            <a:r>
+              <a:rPr lang="en-US" sz="1200" dirty="0" err="1"/>
+              <a:t>zsite</a:t>
+            </a:r>
+            <a:r>
+              <a:rPr lang="en-US" sz="1200" dirty="0"/>
+              <a:t>);</a:t>
+            </a:r>
+          </a:p>
+          <a:p>
+            <a:pPr marL="0" indent="0">
+              <a:lnSpc>
+                <a:spcPct val="100000"/>
+              </a:lnSpc>
+              <a:spcBef>
+                <a:spcPts val="0"/>
+              </a:spcBef>
+              <a:buNone/>
+            </a:pPr>
+            <a:r>
+              <a:rPr lang="en-US" sz="1200" dirty="0"/>
+              <a:t>    /* distance function from wall */</a:t>
+            </a:r>
+          </a:p>
+          <a:p>
+            <a:pPr marL="0" indent="0">
+              <a:lnSpc>
+                <a:spcPct val="100000"/>
+              </a:lnSpc>
+              <a:spcBef>
+                <a:spcPts val="0"/>
+              </a:spcBef>
+              <a:buNone/>
+            </a:pPr>
+            <a:r>
+              <a:rPr lang="en-US" sz="1200" dirty="0"/>
+              <a:t>    wd    .load("wd",   </a:t>
+            </a:r>
+            <a:r>
+              <a:rPr lang="en-US" sz="1200" dirty="0" err="1"/>
+              <a:t>ts</a:t>
+            </a:r>
+            <a:r>
+              <a:rPr lang="en-US" sz="1200" dirty="0"/>
+              <a:t>);  // load as an initial value</a:t>
+            </a:r>
+          </a:p>
+          <a:p>
+            <a:pPr marL="0" indent="0">
+              <a:lnSpc>
+                <a:spcPct val="100000"/>
+              </a:lnSpc>
+              <a:spcBef>
+                <a:spcPts val="0"/>
+              </a:spcBef>
+              <a:buNone/>
+            </a:pPr>
+            <a:r>
+              <a:rPr lang="en-US" sz="1200" dirty="0"/>
+              <a:t>    </a:t>
+            </a:r>
+            <a:r>
+              <a:rPr lang="en-US" sz="1200" dirty="0" err="1"/>
+              <a:t>sdummy</a:t>
+            </a:r>
+            <a:r>
+              <a:rPr lang="en-US" sz="1200" dirty="0"/>
+              <a:t> = 0.0;             // reset source term</a:t>
+            </a:r>
+          </a:p>
+          <a:p>
+            <a:pPr marL="0" indent="0">
+              <a:lnSpc>
+                <a:spcPct val="100000"/>
+              </a:lnSpc>
+              <a:spcBef>
+                <a:spcPts val="0"/>
+              </a:spcBef>
+              <a:buNone/>
+            </a:pPr>
+            <a:r>
+              <a:rPr lang="en-US" sz="1200" dirty="0"/>
+              <a:t>    </a:t>
+            </a:r>
+            <a:r>
+              <a:rPr lang="en-US" sz="1200" dirty="0" err="1"/>
+              <a:t>di.compute</a:t>
+            </a:r>
+            <a:r>
+              <a:rPr lang="en-US" sz="1200" dirty="0"/>
+              <a:t>();</a:t>
+            </a:r>
+          </a:p>
+          <a:p>
+            <a:pPr marL="0" indent="0">
+              <a:lnSpc>
+                <a:spcPct val="100000"/>
+              </a:lnSpc>
+              <a:spcBef>
+                <a:spcPts val="0"/>
+              </a:spcBef>
+              <a:buNone/>
+            </a:pPr>
+            <a:r>
+              <a:rPr lang="en-US" sz="1200" dirty="0"/>
+              <a:t>#endif</a:t>
+            </a:r>
+          </a:p>
+          <a:p>
+            <a:pPr marL="0" indent="0">
+              <a:lnSpc>
+                <a:spcPct val="100000"/>
+              </a:lnSpc>
+              <a:spcBef>
+                <a:spcPts val="0"/>
+              </a:spcBef>
+              <a:buNone/>
+            </a:pPr>
+            <a:r>
+              <a:rPr lang="en-US" sz="1200" dirty="0"/>
+              <a:t>    /* calculate step in case of restart */</a:t>
+            </a:r>
+          </a:p>
+          <a:p>
+            <a:pPr marL="0" indent="0">
+              <a:lnSpc>
+                <a:spcPct val="100000"/>
+              </a:lnSpc>
+              <a:spcBef>
+                <a:spcPts val="0"/>
+              </a:spcBef>
+              <a:buNone/>
+            </a:pPr>
+            <a:r>
+              <a:rPr lang="en-US" sz="1200" dirty="0"/>
+              <a:t>    </a:t>
+            </a:r>
+            <a:r>
+              <a:rPr lang="en-US" sz="1200" dirty="0" err="1"/>
+              <a:t>update_step</a:t>
+            </a:r>
+            <a:r>
+              <a:rPr lang="en-US" sz="1200" dirty="0"/>
+              <a:t>(c, step, </a:t>
+            </a:r>
+            <a:r>
+              <a:rPr lang="en-US" sz="1200" dirty="0" err="1"/>
+              <a:t>sdummy</a:t>
+            </a:r>
+            <a:r>
+              <a:rPr lang="en-US" sz="1200" dirty="0"/>
+              <a:t>);</a:t>
+            </a:r>
+          </a:p>
+          <a:p>
+            <a:pPr marL="0" indent="0">
+              <a:lnSpc>
+                <a:spcPct val="100000"/>
+              </a:lnSpc>
+              <a:spcBef>
+                <a:spcPts val="0"/>
+              </a:spcBef>
+              <a:buNone/>
+            </a:pPr>
+            <a:r>
+              <a:rPr lang="en-US" sz="1200" dirty="0"/>
+              <a:t>  }</a:t>
             </a:r>
           </a:p>
         </p:txBody>
@@ -4194,7 +5174,7 @@
     </p:spTree>
     <p:extLst>
       <p:ext uri="{BB962C8B-B14F-4D97-AF65-F5344CB8AC3E}">
-        <p14:creationId xmlns:p14="http://schemas.microsoft.com/office/powerpoint/2010/main" val="1659136960"/>
+        <p14:creationId xmlns:p14="http://schemas.microsoft.com/office/powerpoint/2010/main" val="3122882228"/>
       </p:ext>
     </p:extLst>
   </p:cSld>
@@ -4223,6 +5203,121 @@
       </p:grpSpPr>
       <p:sp>
         <p:nvSpPr>
+          <p:cNvPr id="2" name="Title 1"/>
+          <p:cNvSpPr>
+            <a:spLocks noGrp="1"/>
+          </p:cNvSpPr>
+          <p:nvPr>
+            <p:ph type="title"/>
+          </p:nvPr>
+        </p:nvSpPr>
+        <p:spPr/>
+        <p:txBody>
+          <a:bodyPr/>
+          <a:lstStyle/>
+          <a:p>
+            <a:r>
+              <a:rPr lang="en-US" dirty="0"/>
+              <a:t>New or updated code (</a:t>
+            </a:r>
+            <a:r>
+              <a:rPr lang="en-US" dirty="0" err="1"/>
+              <a:t>github</a:t>
+            </a:r>
+            <a:r>
+              <a:rPr lang="en-US" dirty="0"/>
+              <a:t>)</a:t>
+            </a:r>
+          </a:p>
+        </p:txBody>
+      </p:sp>
+      <p:sp>
+        <p:nvSpPr>
+          <p:cNvPr id="3" name="Content Placeholder 2"/>
+          <p:cNvSpPr>
+            <a:spLocks noGrp="1"/>
+          </p:cNvSpPr>
+          <p:nvPr>
+            <p:ph idx="1"/>
+          </p:nvPr>
+        </p:nvSpPr>
+        <p:spPr/>
+        <p:txBody>
+          <a:bodyPr/>
+          <a:lstStyle/>
+          <a:p>
+            <a:r>
+              <a:rPr lang="en-US" dirty="0"/>
+              <a:t>Add Utilities/</a:t>
+            </a:r>
+            <a:r>
+              <a:rPr lang="en-US" dirty="0" err="1"/>
+              <a:t>ChangeGrid</a:t>
+            </a:r>
+            <a:endParaRPr lang="en-US" dirty="0"/>
+          </a:p>
+          <a:p>
+            <a:r>
+              <a:rPr lang="en-US" dirty="0"/>
+              <a:t>Modify </a:t>
+            </a:r>
+            <a:r>
+              <a:rPr lang="en-US" dirty="0" err="1"/>
+              <a:t>domain.h</a:t>
+            </a:r>
+            <a:r>
+              <a:rPr lang="en-US" dirty="0"/>
+              <a:t>, and add domain_save.cpp</a:t>
+            </a:r>
+          </a:p>
+          <a:p>
+            <a:r>
+              <a:rPr lang="en-US" dirty="0"/>
+              <a:t>main.cpp (add </a:t>
+            </a:r>
+            <a:r>
+              <a:rPr lang="en-US" dirty="0" err="1"/>
+              <a:t>dom.save</a:t>
+            </a:r>
+            <a:r>
+              <a:rPr lang="en-US" dirty="0"/>
+              <a:t>(g4.dom))</a:t>
+            </a:r>
+          </a:p>
+        </p:txBody>
+      </p:sp>
+    </p:spTree>
+    <p:extLst>
+      <p:ext uri="{BB962C8B-B14F-4D97-AF65-F5344CB8AC3E}">
+        <p14:creationId xmlns:p14="http://schemas.microsoft.com/office/powerpoint/2010/main" val="1659136960"/>
+      </p:ext>
+    </p:extLst>
+  </p:cSld>
+  <p:clrMapOvr>
+    <a:masterClrMapping/>
+  </p:clrMapOvr>
+</p:sld>
+</file>
+
+<file path=ppt/slides/slide4.xml><?xml version="1.0" encoding="utf-8"?>
+<p:sld xmlns:a="http://schemas.openxmlformats.org/drawingml/2006/main" xmlns:r="http://schemas.openxmlformats.org/officeDocument/2006/relationships" xmlns:p="http://schemas.openxmlformats.org/presentationml/2006/main">
+  <p:cSld>
+    <p:spTree>
+      <p:nvGrpSpPr>
+        <p:cNvPr id="1" name=""/>
+        <p:cNvGrpSpPr/>
+        <p:nvPr/>
+      </p:nvGrpSpPr>
+      <p:grpSpPr>
+        <a:xfrm>
+          <a:off x="0" y="0"/>
+          <a:ext cx="0" cy="0"/>
+          <a:chOff x="0" y="0"/>
+          <a:chExt cx="0" cy="0"/>
+        </a:xfrm>
+      </p:grpSpPr>
+      <p:sp>
+        <p:nvSpPr>
           <p:cNvPr id="4" name="TextBox 3"/>
           <p:cNvSpPr txBox="1"/>
           <p:nvPr/>
@@ -4680,7 +5775,7 @@
 </p:sld>
 </file>
 
-<file path=ppt/slides/slide4.xml><?xml version="1.0" encoding="utf-8"?>
+<file path=ppt/slides/slide5.xml><?xml version="1.0" encoding="utf-8"?>
 <p:sld xmlns:a="http://schemas.openxmlformats.org/drawingml/2006/main" xmlns:r="http://schemas.openxmlformats.org/officeDocument/2006/relationships" xmlns:p="http://schemas.openxmlformats.org/presentationml/2006/main">
   <p:cSld>
     <p:spTree>

</xml_diff>